<commit_message>
Update to v5.0.0, remove snap linking
</commit_message>
<xml_diff>
--- a/docs/assets/Caroline_drawings.pptx
+++ b/docs/assets/Caroline_drawings.pptx
@@ -260,7 +260,7 @@
           <a:p>
             <a:fld id="{9BFBA175-CEA6-974F-BECD-C1A384BB3024}" type="datetimeFigureOut">
               <a:rPr lang="en-US" smtClean="0"/>
-              <a:t>8/28/26</a:t>
+              <a:t>10/5/26</a:t>
             </a:fld>
             <a:endParaRPr lang="en-US"/>
           </a:p>
@@ -458,7 +458,7 @@
           <a:p>
             <a:fld id="{9BFBA175-CEA6-974F-BECD-C1A384BB3024}" type="datetimeFigureOut">
               <a:rPr lang="en-US" smtClean="0"/>
-              <a:t>8/28/26</a:t>
+              <a:t>10/5/26</a:t>
             </a:fld>
             <a:endParaRPr lang="en-US"/>
           </a:p>
@@ -666,7 +666,7 @@
           <a:p>
             <a:fld id="{9BFBA175-CEA6-974F-BECD-C1A384BB3024}" type="datetimeFigureOut">
               <a:rPr lang="en-US" smtClean="0"/>
-              <a:t>8/28/26</a:t>
+              <a:t>10/5/26</a:t>
             </a:fld>
             <a:endParaRPr lang="en-US"/>
           </a:p>
@@ -864,7 +864,7 @@
           <a:p>
             <a:fld id="{9BFBA175-CEA6-974F-BECD-C1A384BB3024}" type="datetimeFigureOut">
               <a:rPr lang="en-US" smtClean="0"/>
-              <a:t>8/28/26</a:t>
+              <a:t>10/5/26</a:t>
             </a:fld>
             <a:endParaRPr lang="en-US"/>
           </a:p>
@@ -1139,7 +1139,7 @@
           <a:p>
             <a:fld id="{9BFBA175-CEA6-974F-BECD-C1A384BB3024}" type="datetimeFigureOut">
               <a:rPr lang="en-US" smtClean="0"/>
-              <a:t>8/28/26</a:t>
+              <a:t>10/5/26</a:t>
             </a:fld>
             <a:endParaRPr lang="en-US"/>
           </a:p>
@@ -1404,7 +1404,7 @@
           <a:p>
             <a:fld id="{9BFBA175-CEA6-974F-BECD-C1A384BB3024}" type="datetimeFigureOut">
               <a:rPr lang="en-US" smtClean="0"/>
-              <a:t>8/28/26</a:t>
+              <a:t>10/5/26</a:t>
             </a:fld>
             <a:endParaRPr lang="en-US"/>
           </a:p>
@@ -1816,7 +1816,7 @@
           <a:p>
             <a:fld id="{9BFBA175-CEA6-974F-BECD-C1A384BB3024}" type="datetimeFigureOut">
               <a:rPr lang="en-US" smtClean="0"/>
-              <a:t>8/28/26</a:t>
+              <a:t>10/5/26</a:t>
             </a:fld>
             <a:endParaRPr lang="en-US"/>
           </a:p>
@@ -1957,7 +1957,7 @@
           <a:p>
             <a:fld id="{9BFBA175-CEA6-974F-BECD-C1A384BB3024}" type="datetimeFigureOut">
               <a:rPr lang="en-US" smtClean="0"/>
-              <a:t>8/28/26</a:t>
+              <a:t>10/5/26</a:t>
             </a:fld>
             <a:endParaRPr lang="en-US"/>
           </a:p>
@@ -2070,7 +2070,7 @@
           <a:p>
             <a:fld id="{9BFBA175-CEA6-974F-BECD-C1A384BB3024}" type="datetimeFigureOut">
               <a:rPr lang="en-US" smtClean="0"/>
-              <a:t>8/28/26</a:t>
+              <a:t>10/5/26</a:t>
             </a:fld>
             <a:endParaRPr lang="en-US"/>
           </a:p>
@@ -2381,7 +2381,7 @@
           <a:p>
             <a:fld id="{9BFBA175-CEA6-974F-BECD-C1A384BB3024}" type="datetimeFigureOut">
               <a:rPr lang="en-US" smtClean="0"/>
-              <a:t>8/28/26</a:t>
+              <a:t>10/5/26</a:t>
             </a:fld>
             <a:endParaRPr lang="en-US"/>
           </a:p>
@@ -2669,7 +2669,7 @@
           <a:p>
             <a:fld id="{9BFBA175-CEA6-974F-BECD-C1A384BB3024}" type="datetimeFigureOut">
               <a:rPr lang="en-US" smtClean="0"/>
-              <a:t>8/28/26</a:t>
+              <a:t>10/5/26</a:t>
             </a:fld>
             <a:endParaRPr lang="en-US"/>
           </a:p>
@@ -2910,7 +2910,7 @@
           <a:p>
             <a:fld id="{9BFBA175-CEA6-974F-BECD-C1A384BB3024}" type="datetimeFigureOut">
               <a:rPr lang="en-US" smtClean="0"/>
-              <a:t>8/28/26</a:t>
+              <a:t>10/5/26</a:t>
             </a:fld>
             <a:endParaRPr lang="en-US"/>
           </a:p>
@@ -8553,18 +8553,20 @@
           </p:cNvPr>
           <p:cNvCxnSpPr>
             <a:cxnSpLocks/>
-            <a:stCxn id="124" idx="1"/>
+            <a:stCxn id="125" idx="0"/>
             <a:endCxn id="203" idx="0"/>
           </p:cNvCxnSpPr>
           <p:nvPr/>
         </p:nvCxnSpPr>
         <p:spPr>
-          <a:xfrm rot="10800000" flipV="1">
-            <a:off x="7101228" y="2217435"/>
-            <a:ext cx="133597" cy="1146931"/>
-          </a:xfrm>
-          <a:prstGeom prst="bentConnector2">
-            <a:avLst/>
+          <a:xfrm rot="16200000" flipH="1" flipV="1">
+            <a:off x="6500741" y="1854385"/>
+            <a:ext cx="2110468" cy="909495"/>
+          </a:xfrm>
+          <a:prstGeom prst="bentConnector3">
+            <a:avLst>
+              <a:gd name="adj1" fmla="val -5490"/>
+            </a:avLst>
           </a:prstGeom>
           <a:ln w="38100">
             <a:prstDash val="dash"/>
@@ -9029,7 +9031,7 @@
         <p:spPr>
           <a:xfrm>
             <a:off x="1420935" y="4242051"/>
-            <a:ext cx="1721305" cy="276999"/>
+            <a:ext cx="1113895" cy="276999"/>
           </a:xfrm>
           <a:prstGeom prst="rect">
             <a:avLst/>
@@ -9044,7 +9046,7 @@
           <a:p>
             <a:r>
               <a:rPr lang="en-US" sz="1200" noProof="1"/>
-              <a:t>parameter files (config)</a:t>
+              <a:t>parameter file</a:t>
             </a:r>
           </a:p>
         </p:txBody>
@@ -9369,8 +9371,8 @@
         </p:nvSpPr>
         <p:spPr>
           <a:xfrm>
-            <a:off x="7744733" y="2610834"/>
-            <a:ext cx="1188687" cy="443853"/>
+            <a:off x="7744733" y="2610835"/>
+            <a:ext cx="1188687" cy="300018"/>
           </a:xfrm>
           <a:prstGeom prst="rect">
             <a:avLst/>
@@ -9422,7 +9424,7 @@
         <p:spPr>
           <a:xfrm>
             <a:off x="7725783" y="2638854"/>
-            <a:ext cx="1207637" cy="461665"/>
+            <a:ext cx="1207637" cy="276999"/>
           </a:xfrm>
           <a:prstGeom prst="rect">
             <a:avLst/>
@@ -9437,7 +9439,7 @@
           <a:p>
             <a:r>
               <a:rPr lang="en-US" sz="1200" noProof="1"/>
-              <a:t>generate_partitioned_STM</a:t>
+              <a:t>generate_STM</a:t>
             </a:r>
           </a:p>
         </p:txBody>
@@ -9513,11 +9515,11 @@
         <p:spPr>
           <a:xfrm>
             <a:off x="6406042" y="1954608"/>
-            <a:ext cx="1319741" cy="915079"/>
+            <a:ext cx="1319741" cy="822746"/>
           </a:xfrm>
           <a:prstGeom prst="bentConnector3">
             <a:avLst>
-              <a:gd name="adj1" fmla="val 31804"/>
+              <a:gd name="adj1" fmla="val 47153"/>
             </a:avLst>
           </a:prstGeom>
           <a:ln w="38100">
@@ -9675,8 +9677,8 @@
         </p:nvSpPr>
         <p:spPr>
           <a:xfrm>
-            <a:off x="3536956" y="2826571"/>
-            <a:ext cx="1138447" cy="409479"/>
+            <a:off x="3536957" y="2891438"/>
+            <a:ext cx="1138447" cy="262856"/>
           </a:xfrm>
           <a:prstGeom prst="rect">
             <a:avLst/>
@@ -9727,8 +9729,8 @@
         </p:nvSpPr>
         <p:spPr>
           <a:xfrm>
-            <a:off x="3542903" y="2809406"/>
-            <a:ext cx="1085842" cy="461665"/>
+            <a:off x="3542155" y="2907397"/>
+            <a:ext cx="1176879" cy="276999"/>
           </a:xfrm>
           <a:prstGeom prst="rect">
             <a:avLst/>
@@ -9743,7 +9745,7 @@
           <a:p>
             <a:r>
               <a:rPr lang="en-US" sz="1200" noProof="1"/>
-              <a:t>SNAP_fix_permissions</a:t>
+              <a:t>SNAP_cleanup</a:t>
             </a:r>
           </a:p>
         </p:txBody>
@@ -9811,12 +9813,12 @@
         </p:nvCxnSpPr>
         <p:spPr>
           <a:xfrm rot="10800000" flipV="1">
-            <a:off x="3536957" y="2654397"/>
-            <a:ext cx="14733" cy="376914"/>
+            <a:off x="3536957" y="2654396"/>
+            <a:ext cx="14732" cy="368469"/>
           </a:xfrm>
           <a:prstGeom prst="bentConnector3">
             <a:avLst>
-              <a:gd name="adj1" fmla="val 1150085"/>
+              <a:gd name="adj1" fmla="val 1177315"/>
             </a:avLst>
           </a:prstGeom>
           <a:ln w="38100">
@@ -10075,12 +10077,12 @@
         </p:nvCxnSpPr>
         <p:spPr>
           <a:xfrm flipV="1">
-            <a:off x="4675403" y="2494635"/>
-            <a:ext cx="467080" cy="536676"/>
+            <a:off x="4675404" y="2494635"/>
+            <a:ext cx="467079" cy="528231"/>
           </a:xfrm>
           <a:prstGeom prst="bentConnector3">
             <a:avLst>
-              <a:gd name="adj1" fmla="val 50000"/>
+              <a:gd name="adj1" fmla="val 47506"/>
             </a:avLst>
           </a:prstGeom>
           <a:ln w="38100">
@@ -10113,14 +10115,15 @@
           </p:cNvPr>
           <p:cNvCxnSpPr>
             <a:cxnSpLocks/>
+            <a:stCxn id="123" idx="3"/>
             <a:endCxn id="46" idx="1"/>
           </p:cNvCxnSpPr>
           <p:nvPr/>
         </p:nvCxnSpPr>
         <p:spPr>
           <a:xfrm flipV="1">
-            <a:off x="4705035" y="2912065"/>
-            <a:ext cx="420656" cy="119995"/>
+            <a:off x="4675404" y="2912065"/>
+            <a:ext cx="450287" cy="110801"/>
           </a:xfrm>
           <a:prstGeom prst="bentConnector3">
             <a:avLst>
@@ -10164,12 +10167,12 @@
         </p:nvCxnSpPr>
         <p:spPr>
           <a:xfrm flipV="1">
-            <a:off x="6494024" y="2869687"/>
-            <a:ext cx="1231759" cy="42378"/>
+            <a:off x="6494024" y="2777354"/>
+            <a:ext cx="1231759" cy="134711"/>
           </a:xfrm>
           <a:prstGeom prst="bentConnector3">
             <a:avLst>
-              <a:gd name="adj1" fmla="val 27504"/>
+              <a:gd name="adj1" fmla="val 43898"/>
             </a:avLst>
           </a:prstGeom>
           <a:ln w="38100">

</xml_diff>